<commit_message>
Publish D13 revised original PowerPoint and matching PDF
</commit_message>
<xml_diff>
--- a/heater/electrical/d13/Heating_Rate_Controller_D13_Styled_DRAFT.pptx
+++ b/heater/electrical/d13/Heating_Rate_Controller_D13_Styled_DRAFT.pptx
@@ -4022,19 +4022,19 @@
         </p:spPr>
         <p:txBody>
           <a:bodyPr wrap="none" lIns="10972" tIns="0" rIns="10972" bIns="0" anchor="ctr">
-            <a:spAutoFit/>
+            <a:normAutofit/>
           </a:bodyPr>
           <a:lstStyle/>
           <a:p>
             <a:pPr algn="l"/>
             <a:r>
-              <a:rPr sz="930" b="0">
+              <a:rPr sz="1100" b="0">
                 <a:solidFill>
                   <a:srgbClr val="607084"/>
                 </a:solidFill>
                 <a:latin typeface="Aptos"/>
               </a:rPr>
-              <a:t>Logical bus · terminals TBD</a:t>
+              <a:t>3 outgoing L/N/PE; terminals TBD</a:t>
             </a:r>
           </a:p>
         </p:txBody>
@@ -7750,19 +7750,19 @@
         </p:spPr>
         <p:txBody>
           <a:bodyPr wrap="none" lIns="10972" tIns="0" rIns="10972" bIns="0" anchor="ctr">
-            <a:spAutoFit/>
+            <a:normAutofit/>
           </a:bodyPr>
           <a:lstStyle/>
           <a:p>
             <a:pPr algn="l"/>
             <a:r>
-              <a:rPr sz="950" b="0">
+              <a:rPr sz="1040" b="0">
                 <a:solidFill>
                   <a:srgbClr val="A35B1B"/>
                 </a:solidFill>
                 <a:latin typeface="Aptos"/>
               </a:rPr>
-              <a:t>Confirm X1 terminal blocks and jumpers, DD11 output tabs / fuse, PE bonds, and 24 V interlock design.</a:t>
+              <a:t>X1: 3 outgoing L (PS1, S1-A input, S2-A input) and 3 outgoing N (PS1, E1, E2). Incoming L/N, selector outputs and PE bonds are additional wires.</a:t>
             </a:r>
           </a:p>
         </p:txBody>
@@ -7785,7 +7785,7 @@
         </p:spPr>
         <p:txBody>
           <a:bodyPr wrap="none" lIns="10972" tIns="0" rIns="10972" bIns="0" anchor="ctr">
-            <a:spAutoFit/>
+            <a:normAutofit/>
           </a:bodyPr>
           <a:lstStyle/>
           <a:p>
@@ -7797,7 +7797,7 @@
                 </a:solidFill>
                 <a:latin typeface="Aptos"/>
               </a:rPr>
-              <a:t>HEATING RATE CONTROLLER   /   D12 SOCKET + ACTIVITY LED   /   EDITABLE POWERPOINT</a:t>
+              <a:t>HEATING RATE CONTROLLER   /   D13 SOCKET + ACTIVITY LED   /   EDITABLE POWERPOINT</a:t>
             </a:r>
           </a:p>
         </p:txBody>
@@ -7820,7 +7820,7 @@
         </p:spPr>
         <p:txBody>
           <a:bodyPr wrap="none" lIns="10972" tIns="0" rIns="10972" bIns="0" anchor="ctr">
-            <a:spAutoFit/>
+            <a:normAutofit/>
           </a:bodyPr>
           <a:lstStyle/>
           <a:p>
@@ -7832,7 +7832,7 @@
                 </a:solidFill>
                 <a:latin typeface="Aptos"/>
               </a:rPr>
-              <a:t>SHEET 01 / 01</a:t>
+              <a:t>SHEET 01 / 11</a:t>
             </a:r>
           </a:p>
         </p:txBody>
@@ -8122,7 +8122,7 @@
         </p:spPr>
         <p:txBody>
           <a:bodyPr wrap="none" lIns="9144" tIns="0" rIns="9144" bIns="0" anchor="ctr">
-            <a:spAutoFit/>
+            <a:normAutofit/>
           </a:bodyPr>
           <a:lstStyle/>
           <a:p>
@@ -8134,7 +8134,7 @@
                 </a:solidFill>
                 <a:latin typeface="Aptos"/>
               </a:rPr>
-              <a:t>HEATING RATE CONTROLLER   /   D12 BLOCK + PORT SCHEMATICS   /   EDITABLE POWERPOINT</a:t>
+              <a:t>HEATING RATE CONTROLLER   /   D13 BLOCK + PORT SCHEMATICS   /   EDITABLE POWERPOINT</a:t>
             </a:r>
           </a:p>
         </p:txBody>
@@ -8192,19 +8192,19 @@
         </p:spPr>
         <p:txBody>
           <a:bodyPr wrap="none" lIns="9144" tIns="0" rIns="9144" bIns="0" anchor="ctr">
-            <a:spAutoFit/>
+            <a:normAutofit/>
           </a:bodyPr>
           <a:lstStyle/>
           <a:p>
             <a:pPr algn="l"/>
             <a:r>
-              <a:rPr sz="835" b="0">
+              <a:rPr sz="1030" b="0">
                 <a:solidFill>
                   <a:srgbClr val="607084"/>
                 </a:solidFill>
                 <a:latin typeface="Aptos"/>
               </a:rPr>
-              <a:t>The Finder 13.61 power-up OFF state, switch actual terminals and DC protection must still be verified.</a:t>
+              <a:t>K1/K2 RI step mode proposed; orange timer applies only to IT; hardware return-to-OFF is unverified.</a:t>
             </a:r>
           </a:p>
         </p:txBody>
@@ -8310,19 +8310,19 @@
         </p:spPr>
         <p:txBody>
           <a:bodyPr wrap="square" lIns="9144" tIns="0" rIns="9144" bIns="0" anchor="ctr">
-            <a:spAutoFit/>
+            <a:normAutofit/>
           </a:bodyPr>
           <a:lstStyle/>
           <a:p>
             <a:pPr algn="l"/>
             <a:r>
-              <a:rPr sz="969" b="0">
+              <a:rPr sz="1150" b="0">
                 <a:solidFill>
                   <a:srgbClr val="1F344E"/>
                 </a:solidFill>
                 <a:latin typeface="Aptos"/>
               </a:rPr>
-              <a:t>X3/4:+24 → Finder 13.61 power &amp; 11; button C.  X2:0V → Finder supply return, SK3/4:A2 and EAO LED−.</a:t>
+              <a:t>X3/4 gated +24 -&gt; Finder K1/2:A1 and 11; EAO SB1/2 COM. 0 V -&gt; K1/2:A2, K3/4:A2 and ENABLE LED-.</a:t>
             </a:r>
           </a:p>
         </p:txBody>
@@ -8428,19 +8428,19 @@
         </p:spPr>
         <p:txBody>
           <a:bodyPr wrap="square" lIns="9144" tIns="0" rIns="9144" bIns="0" anchor="ctr">
-            <a:spAutoFit/>
+            <a:normAutofit/>
           </a:bodyPr>
           <a:lstStyle/>
           <a:p>
             <a:pPr algn="l"/>
             <a:r>
-              <a:rPr sz="969" b="0">
+              <a:rPr sz="1150" b="0">
                 <a:solidFill>
                   <a:srgbClr val="1F344E"/>
                 </a:solidFill>
                 <a:latin typeface="Aptos"/>
               </a:rPr>
-              <a:t>EAO SB1/2:NO → Finder K1/2:3 impulse; EAO C uses channel-gated +24 V.</a:t>
+              <a:t>EAO SB1/2:NO -&gt; Finder K1/2:3; EAO COM = gated +24 V, but actual central contact marking must be checked.</a:t>
             </a:r>
           </a:p>
         </p:txBody>
@@ -8900,19 +8900,19 @@
         </p:spPr>
         <p:txBody>
           <a:bodyPr wrap="square" lIns="9144" tIns="0" rIns="9144" bIns="0" anchor="ctr">
-            <a:spAutoFit/>
+            <a:normAutofit/>
           </a:bodyPr>
           <a:lstStyle/>
           <a:p>
             <a:pPr algn="l"/>
             <a:r>
-              <a:rPr sz="969" b="0">
+              <a:rPr sz="1150" b="0">
                 <a:solidFill>
                   <a:srgbClr val="1F344E"/>
                 </a:solidFill>
                 <a:latin typeface="Aptos"/>
               </a:rPr>
-              <a:t>Gated +24 → SSR+3 AND activity HL+; SSR−4 AND activity HL− → W:13; W:14 → 0V.</a:t>
+              <a:t>Gated +24 shared at EAO COM -&gt; Crydom +3 and ACTIVE+; Crydom -4 and ACTIVE- -&gt; W:13; W:14 -&gt; 0 V.</a:t>
             </a:r>
           </a:p>
         </p:txBody>
@@ -9289,19 +9289,19 @@
         </p:spPr>
         <p:txBody>
           <a:bodyPr wrap="none" lIns="9144" tIns="0" rIns="9144" bIns="0" anchor="ctr">
-            <a:spAutoFit/>
+            <a:normAutofit/>
           </a:bodyPr>
           <a:lstStyle/>
           <a:p>
             <a:pPr algn="l"/>
             <a:r>
-              <a:rPr sz="900" b="0">
+              <a:rPr sz="1050" b="0">
                 <a:solidFill>
                   <a:srgbClr val="A35B1B"/>
                 </a:solidFill>
                 <a:latin typeface="Aptos"/>
               </a:rPr>
-              <a:t>These are net-level circuit proposals, NOT numbered physical wires. Final wire IDs, conductor sizes, terminations and current ratings remain to be assigned.</a:t>
+              <a:t>Only 3 available +24 V and 3 common 0 V take-off positions per channel reported. All junctions and real wire IDs require independent check.</a:t>
             </a:r>
           </a:p>
         </p:txBody>
@@ -9591,7 +9591,7 @@
         </p:spPr>
         <p:txBody>
           <a:bodyPr wrap="none" lIns="9144" tIns="0" rIns="9144" bIns="0" anchor="ctr">
-            <a:spAutoFit/>
+            <a:normAutofit/>
           </a:bodyPr>
           <a:lstStyle/>
           <a:p>
@@ -9603,7 +9603,7 @@
                 </a:solidFill>
                 <a:latin typeface="Aptos"/>
               </a:rPr>
-              <a:t>HEATING RATE CONTROLLER   /   D12 BLOCK + PORT SCHEMATICS   /   EDITABLE POWERPOINT</a:t>
+              <a:t>HEATING RATE CONTROLLER   /   D13 BLOCK + PORT SCHEMATICS   /   EDITABLE POWERPOINT</a:t>
             </a:r>
           </a:p>
         </p:txBody>
@@ -9661,19 +9661,19 @@
         </p:spPr>
         <p:txBody>
           <a:bodyPr wrap="none" lIns="9144" tIns="0" rIns="9144" bIns="0" anchor="ctr">
-            <a:spAutoFit/>
+            <a:normAutofit/>
           </a:bodyPr>
           <a:lstStyle/>
           <a:p>
             <a:pPr algn="l"/>
             <a:r>
-              <a:rPr sz="835" b="0">
+              <a:rPr sz="1030" b="0">
                 <a:solidFill>
                   <a:srgbClr val="607084"/>
                 </a:solidFill>
                 <a:latin typeface="Aptos"/>
               </a:rPr>
-              <a:t>Manufacturer sources are reference points, not proof that the integrated design has passed electrical safety review.</a:t>
+              <a:t>D13 remains a design/inspection draft. Verify actual parts, physical terminals and OFF after power restoration.</a:t>
             </a:r>
           </a:p>
         </p:txBody>
@@ -11004,19 +11004,19 @@
         </p:spPr>
         <p:txBody>
           <a:bodyPr wrap="square" lIns="9144" tIns="0" rIns="9144" bIns="0" anchor="ctr">
-            <a:spAutoFit/>
+            <a:normAutofit/>
           </a:bodyPr>
           <a:lstStyle/>
           <a:p>
             <a:pPr algn="l"/>
             <a:r>
-              <a:rPr sz="910" b="0">
+              <a:rPr sz="1150" b="0">
                 <a:solidFill>
                   <a:srgbClr val="1F344E"/>
                 </a:solidFill>
                 <a:latin typeface="Aptos"/>
               </a:rPr>
-              <a:t>Finder 13.61 must remain OFF after loss and restoration of 24 V; prove minimum interruption and button held states.</a:t>
+              <a:t>K1/K2: RI proposed (white selector); 0.5-20 min orange timer only for IT. Check 24 V return, dips and held ENABLE.</a:t>
             </a:r>
           </a:p>
         </p:txBody>
@@ -11122,19 +11122,19 @@
         </p:spPr>
         <p:txBody>
           <a:bodyPr wrap="square" lIns="9144" tIns="0" rIns="9144" bIns="0" anchor="ctr">
-            <a:spAutoFit/>
+            <a:normAutofit/>
           </a:bodyPr>
           <a:lstStyle/>
           <a:p>
             <a:pPr algn="l"/>
             <a:r>
-              <a:rPr sz="910" b="0">
+              <a:rPr sz="1150" b="0">
                 <a:solidFill>
                   <a:srgbClr val="1F344E"/>
                 </a:solidFill>
                 <a:latin typeface="Aptos"/>
               </a:rPr>
-              <a:t>Confirm X1–X4 blocks, Schneider S1/S2 B-contact terminal stamps (23/24* IEC intended), J1 tabs and Finder 62.31 sockets.</a:t>
+              <a:t>Check 3 L and 3 N outgoing mains taps, PSU/inlet, selectors, distribution blocks, jumpers and protective earth.</a:t>
             </a:r>
           </a:p>
         </p:txBody>
@@ -11240,19 +11240,19 @@
         </p:spPr>
         <p:txBody>
           <a:bodyPr wrap="square" lIns="9144" tIns="0" rIns="9144" bIns="0" anchor="ctr">
-            <a:spAutoFit/>
+            <a:normAutofit/>
           </a:bodyPr>
           <a:lstStyle/>
           <a:p>
             <a:pPr algn="l"/>
             <a:r>
-              <a:rPr sz="910" b="0">
+              <a:rPr sz="1150" b="0">
                 <a:solidFill>
                   <a:srgbClr val="1F344E"/>
                 </a:solidFill>
                 <a:latin typeface="Aptos"/>
               </a:rPr>
-              <a:t>Verify 15 A DC continuity ratings, breaker/source fault coordination, cable size and connector ratings.</a:t>
+              <a:t>Inspect 15 A DC path: socket ratings, relay/SSR polarity, fault protection, conductor sizing and heat dissipation.</a:t>
             </a:r>
           </a:p>
         </p:txBody>
@@ -11358,19 +11358,19 @@
         </p:spPr>
         <p:txBody>
           <a:bodyPr wrap="square" lIns="9144" tIns="0" rIns="9144" bIns="0" anchor="ctr">
-            <a:spAutoFit/>
+            <a:normAutofit/>
           </a:bodyPr>
           <a:lstStyle/>
           <a:p>
             <a:pPr algn="l"/>
             <a:r>
-              <a:rPr sz="910" b="0">
+              <a:rPr sz="1150" b="0">
                 <a:solidFill>
                   <a:srgbClr val="1F344E"/>
                 </a:solidFill>
                 <a:latin typeface="Aptos"/>
               </a:rPr>
-              <a:t>Validate SSR heat sink, W1/W2 100 mA output (SSR+LED 35 mA max calculated), PE and emergency disconnection.</a:t>
+              <a:t>Inspect EAO COM vs LED+; Crydom+3 &amp; ACTIVE+ = gated +24; Crydom-4 &amp; ACTIVE- to W:13; W:14 to 0 V.</a:t>
             </a:r>
           </a:p>
         </p:txBody>
@@ -11476,19 +11476,19 @@
         </p:spPr>
         <p:txBody>
           <a:bodyPr wrap="square" lIns="9144" tIns="0" rIns="9144" bIns="0" anchor="ctr">
-            <a:spAutoFit/>
+            <a:normAutofit/>
           </a:bodyPr>
           <a:lstStyle/>
           <a:p>
             <a:pPr algn="l"/>
             <a:r>
-              <a:rPr sz="910" b="0">
+              <a:rPr sz="1150" b="0">
                 <a:solidFill>
                   <a:srgbClr val="1F344E"/>
                 </a:solidFill>
                 <a:latin typeface="Aptos"/>
               </a:rPr>
-              <a:t>Independent safety design review and pre-energisation electrical/function tests by a suitably competent person.</a:t>
+              <a:t>Independent checker: continuity, isolation, PE, protection, start/stop, no auto-restart; record deviations and sign off.</a:t>
             </a:r>
           </a:p>
         </p:txBody>
@@ -11850,7 +11850,7 @@
         </p:spPr>
         <p:txBody>
           <a:bodyPr wrap="none" lIns="9144" tIns="0" rIns="9144" bIns="0" anchor="ctr">
-            <a:spAutoFit/>
+            <a:normAutofit/>
           </a:bodyPr>
           <a:lstStyle/>
           <a:p>
@@ -11862,7 +11862,7 @@
                 </a:solidFill>
                 <a:latin typeface="Aptos"/>
               </a:rPr>
-              <a:t>HEATING RATE CONTROLLER   /   D12 BLOCK + PORT SCHEMATICS   /   EDITABLE POWERPOINT</a:t>
+              <a:t>HEATING RATE CONTROLLER   /   D13 BLOCK + PORT SCHEMATICS   /   EDITABLE POWERPOINT</a:t>
             </a:r>
           </a:p>
         </p:txBody>
@@ -11920,27 +11920,27 @@
         </p:spPr>
         <p:txBody>
           <a:bodyPr wrap="square" lIns="9144" tIns="0" rIns="9144" bIns="0" anchor="ctr">
-            <a:spAutoFit/>
-          </a:bodyPr>
-          <a:lstStyle/>
-          <a:p>
-            <a:r>
-              <a:rPr sz="1030">
+            <a:normAutofit/>
+          </a:bodyPr>
+          <a:lstStyle/>
+          <a:p>
+            <a:r>
+              <a:rPr sz="1100">
                 <a:solidFill>
                   <a:srgbClr val="3F5A6F"/>
                 </a:solidFill>
               </a:rPr>
-              <a:t>Selector terminal references:  A = 13–14 (AC)   |   B = 23–24* (gated +24 V).</a:t>
-            </a:r>
-          </a:p>
-          <a:p>
-            <a:r>
-              <a:rPr sz="1030">
+              <a:t>Selector A = mains NO 13-14; B = gated +24 V NO 23-24* (IEC proposed). Per channel THREE +24 V and THREE 0 V take-off positions are reported. Approved junctions may be necessary. Verify physical contact markings and supply feeds.</a:t>
+            </a:r>
+          </a:p>
+          <a:p>
+            <a:r>
+              <a:rPr sz="1100">
                 <a:solidFill>
                   <a:srgbClr val="3F5A6F"/>
                 </a:solidFill>
               </a:rPr>
-              <a:t>* IEC design labels only. Confirm stamps on the actual XB5AD23 contact-block assembly before wiring; X2–X4 distribution hardware remains TBD.</a:t>
+              <a:t/>
             </a:r>
           </a:p>
         </p:txBody>
@@ -12271,19 +12271,19 @@
         </p:spPr>
         <p:txBody>
           <a:bodyPr wrap="square" lIns="9144" tIns="0" rIns="9144" bIns="0" anchor="ctr">
-            <a:spAutoFit/>
+            <a:normAutofit/>
           </a:bodyPr>
           <a:lstStyle/>
           <a:p>
             <a:pPr algn="l"/>
             <a:r>
-              <a:rPr sz="890" b="0">
+              <a:rPr sz="1100" b="0">
                 <a:solidFill>
                   <a:srgbClr val="607084"/>
                 </a:solidFill>
                 <a:latin typeface="Aptos"/>
               </a:rPr>
-              <a:t>Physical terminals and jumpers TBD</a:t>
+              <a:t>Physical terminals/jumpers TBD</a:t>
             </a:r>
           </a:p>
         </p:txBody>
@@ -15391,7 +15391,7 @@
         </p:spPr>
         <p:txBody>
           <a:bodyPr wrap="none" lIns="9144" tIns="0" rIns="9144" bIns="0" anchor="ctr">
-            <a:spAutoFit/>
+            <a:normAutofit/>
           </a:bodyPr>
           <a:lstStyle/>
           <a:p>
@@ -15403,7 +15403,7 @@
                 </a:solidFill>
                 <a:latin typeface="Aptos"/>
               </a:rPr>
-              <a:t>HEATING RATE CONTROLLER   /   D12 BLOCK + PORT SCHEMATICS   /   EDITABLE POWERPOINT</a:t>
+              <a:t>HEATING RATE CONTROLLER   /   D13 BLOCK + PORT SCHEMATICS   /   EDITABLE POWERPOINT</a:t>
             </a:r>
           </a:p>
         </p:txBody>
@@ -15461,19 +15461,19 @@
         </p:spPr>
         <p:txBody>
           <a:bodyPr wrap="none" lIns="9144" tIns="0" rIns="9144" bIns="0" anchor="ctr">
-            <a:spAutoFit/>
+            <a:normAutofit/>
           </a:bodyPr>
           <a:lstStyle/>
           <a:p>
             <a:pPr algn="l"/>
             <a:r>
-              <a:rPr sz="835" b="0">
+              <a:rPr sz="1050" b="0">
                 <a:solidFill>
                   <a:srgbClr val="607084"/>
                 </a:solidFill>
                 <a:latin typeface="Aptos"/>
               </a:rPr>
-              <a:t>OFF-on-power-restoration and exact Finder supply/trigger/socket terminal markings remain to be verified.</a:t>
+              <a:t>Proposed K1 mode RI (upper selector); orange T timer is only used in IT. Prove OFF on supply return and held ENABLE.</a:t>
             </a:r>
           </a:p>
         </p:txBody>
@@ -17087,7 +17087,7 @@
         </p:spPr>
         <p:txBody>
           <a:bodyPr wrap="none" lIns="9144" tIns="0" rIns="9144" bIns="0" anchor="ctr">
-            <a:spAutoFit/>
+            <a:normAutofit/>
           </a:bodyPr>
           <a:lstStyle/>
           <a:p>
@@ -17099,7 +17099,7 @@
                 </a:solidFill>
                 <a:latin typeface="Aptos"/>
               </a:rPr>
-              <a:t>L/+</a:t>
+              <a:t>A1</a:t>
             </a:r>
           </a:p>
         </p:txBody>
@@ -17794,7 +17794,7 @@
         </p:spPr>
         <p:txBody>
           <a:bodyPr wrap="none" lIns="9144" tIns="0" rIns="9144" bIns="0" anchor="ctr">
-            <a:spAutoFit/>
+            <a:normAutofit/>
           </a:bodyPr>
           <a:lstStyle/>
           <a:p>
@@ -17806,7 +17806,7 @@
                 </a:solidFill>
                 <a:latin typeface="Aptos"/>
               </a:rPr>
-              <a:t>N/−</a:t>
+              <a:t>A2</a:t>
             </a:r>
           </a:p>
         </p:txBody>
@@ -18317,19 +18317,19 @@
         </p:spPr>
         <p:txBody>
           <a:bodyPr wrap="none" lIns="9144" tIns="0" rIns="9144" bIns="0" anchor="ctr">
-            <a:spAutoFit/>
+            <a:normAutofit/>
           </a:bodyPr>
           <a:lstStyle/>
           <a:p>
             <a:pPr algn="l"/>
             <a:r>
-              <a:rPr sz="869" b="0">
+              <a:rPr sz="1100" b="0">
                 <a:solidFill>
                   <a:srgbClr val="607084"/>
                 </a:solidFill>
                 <a:latin typeface="Aptos"/>
               </a:rPr>
-              <a:t>Matching EN reference indicates ONE electrical net (avoids a wire crossing other circuits).</a:t>
+              <a:t>EN1 = K1:14 / K3:A1 / SB1:LED+; SB1 COM is a different gated +24 V node.</a:t>
             </a:r>
           </a:p>
         </p:txBody>
@@ -18352,19 +18352,19 @@
         </p:spPr>
         <p:txBody>
           <a:bodyPr wrap="none" lIns="9144" tIns="0" rIns="9144" bIns="0" anchor="ctr">
-            <a:spAutoFit/>
+            <a:normAutofit/>
           </a:bodyPr>
           <a:lstStyle/>
           <a:p>
             <a:pPr algn="l"/>
             <a:r>
-              <a:rPr sz="850" b="0">
+              <a:rPr sz="1000" b="0">
                 <a:solidFill>
                   <a:srgbClr val="607084"/>
                 </a:solidFill>
                 <a:latin typeface="Aptos"/>
               </a:rPr>
-              <a:t>X3:+24 → button C and K1 L/+,11  |  Button NO → K1:3  |  EN1 → relay coil A1 and LED+  |  0V → K1:N/−, K3:A2, LED−</a:t>
+              <a:t>X3 gated +24 -&gt; SB1 COM, K1:A1 &amp; 11; SB1 NO -&gt; K1:3; EN1(K1:14) -&gt; K3:A1 &amp; SB1 LED+; 0 V -&gt; K1:A2,K3:A2,SB1 LED-.</a:t>
             </a:r>
           </a:p>
         </p:txBody>
@@ -18897,7 +18897,7 @@
         </p:spPr>
         <p:txBody>
           <a:bodyPr wrap="none" lIns="9144" tIns="0" rIns="9144" bIns="0" anchor="ctr">
-            <a:spAutoFit/>
+            <a:normAutofit/>
           </a:bodyPr>
           <a:lstStyle/>
           <a:p>
@@ -18909,7 +18909,7 @@
                 </a:solidFill>
                 <a:latin typeface="Aptos"/>
               </a:rPr>
-              <a:t>HEATING RATE CONTROLLER   /   D12 BLOCK + PORT SCHEMATICS   /   EDITABLE POWERPOINT</a:t>
+              <a:t>HEATING RATE CONTROLLER   /   D13 BLOCK + PORT SCHEMATICS   /   EDITABLE POWERPOINT</a:t>
             </a:r>
           </a:p>
         </p:txBody>
@@ -18967,19 +18967,19 @@
         </p:spPr>
         <p:txBody>
           <a:bodyPr wrap="none" lIns="9144" tIns="0" rIns="9144" bIns="0" anchor="ctr">
-            <a:spAutoFit/>
+            <a:normAutofit/>
           </a:bodyPr>
           <a:lstStyle/>
           <a:p>
             <a:pPr algn="l"/>
             <a:r>
-              <a:rPr sz="835" b="0">
+              <a:rPr sz="1050" b="0">
                 <a:solidFill>
                   <a:srgbClr val="607084"/>
                 </a:solidFill>
                 <a:latin typeface="Aptos"/>
               </a:rPr>
-              <a:t>OFF-on-power-restoration and exact Finder supply/trigger/socket terminal markings remain to be verified.</a:t>
+              <a:t>Proposed K2 mode RI (upper selector); orange T timer is only used in IT. Prove OFF on supply return and held ENABLE.</a:t>
             </a:r>
           </a:p>
         </p:txBody>
@@ -20593,7 +20593,7 @@
         </p:spPr>
         <p:txBody>
           <a:bodyPr wrap="none" lIns="9144" tIns="0" rIns="9144" bIns="0" anchor="ctr">
-            <a:spAutoFit/>
+            <a:normAutofit/>
           </a:bodyPr>
           <a:lstStyle/>
           <a:p>
@@ -20605,7 +20605,7 @@
                 </a:solidFill>
                 <a:latin typeface="Aptos"/>
               </a:rPr>
-              <a:t>L/+</a:t>
+              <a:t>A1</a:t>
             </a:r>
           </a:p>
         </p:txBody>
@@ -21300,7 +21300,7 @@
         </p:spPr>
         <p:txBody>
           <a:bodyPr wrap="none" lIns="9144" tIns="0" rIns="9144" bIns="0" anchor="ctr">
-            <a:spAutoFit/>
+            <a:normAutofit/>
           </a:bodyPr>
           <a:lstStyle/>
           <a:p>
@@ -21312,7 +21312,7 @@
                 </a:solidFill>
                 <a:latin typeface="Aptos"/>
               </a:rPr>
-              <a:t>N/−</a:t>
+              <a:t>A2</a:t>
             </a:r>
           </a:p>
         </p:txBody>
@@ -21823,19 +21823,19 @@
         </p:spPr>
         <p:txBody>
           <a:bodyPr wrap="none" lIns="9144" tIns="0" rIns="9144" bIns="0" anchor="ctr">
-            <a:spAutoFit/>
+            <a:normAutofit/>
           </a:bodyPr>
           <a:lstStyle/>
           <a:p>
             <a:pPr algn="l"/>
             <a:r>
-              <a:rPr sz="869" b="0">
+              <a:rPr sz="1100" b="0">
                 <a:solidFill>
                   <a:srgbClr val="607084"/>
                 </a:solidFill>
                 <a:latin typeface="Aptos"/>
               </a:rPr>
-              <a:t>Matching EN reference indicates ONE electrical net (avoids a wire crossing other circuits).</a:t>
+              <a:t>EN2 = K2:14 / K4:A1 / SB2:LED+; SB2 COM is a different gated +24 V node.</a:t>
             </a:r>
           </a:p>
         </p:txBody>
@@ -21858,19 +21858,19 @@
         </p:spPr>
         <p:txBody>
           <a:bodyPr wrap="none" lIns="9144" tIns="0" rIns="9144" bIns="0" anchor="ctr">
-            <a:spAutoFit/>
+            <a:normAutofit/>
           </a:bodyPr>
           <a:lstStyle/>
           <a:p>
             <a:pPr algn="l"/>
             <a:r>
-              <a:rPr sz="850" b="0">
+              <a:rPr sz="1000" b="0">
                 <a:solidFill>
                   <a:srgbClr val="607084"/>
                 </a:solidFill>
                 <a:latin typeface="Aptos"/>
               </a:rPr>
-              <a:t>X4:+24 → button C and K2 L/+,11  |  Button NO → K2:3  |  EN2 → relay coil A1 and LED+  |  0V → K2:N/−, K4:A2, LED−</a:t>
+              <a:t>X4 gated +24 -&gt; SB2 COM, K2:A1 &amp; 11; SB2 NO -&gt; K2:3; EN2(K2:14) -&gt; K4:A1 &amp; SB2 LED+; 0 V -&gt; K2:A2,K4:A2,SB2 LED-.</a:t>
             </a:r>
           </a:p>
         </p:txBody>
@@ -22403,7 +22403,7 @@
         </p:spPr>
         <p:txBody>
           <a:bodyPr wrap="none" lIns="9144" tIns="0" rIns="9144" bIns="0" anchor="ctr">
-            <a:spAutoFit/>
+            <a:normAutofit/>
           </a:bodyPr>
           <a:lstStyle/>
           <a:p>
@@ -22415,7 +22415,7 @@
                 </a:solidFill>
                 <a:latin typeface="Aptos"/>
               </a:rPr>
-              <a:t>HEATING RATE CONTROLLER   /   D12 BLOCK + PORT SCHEMATICS   /   EDITABLE POWERPOINT</a:t>
+              <a:t>HEATING RATE CONTROLLER   /   D13 BLOCK + PORT SCHEMATICS   /   EDITABLE POWERPOINT</a:t>
             </a:r>
           </a:p>
         </p:txBody>
@@ -22473,19 +22473,19 @@
         </p:spPr>
         <p:txBody>
           <a:bodyPr wrap="none" lIns="9144" tIns="0" rIns="9144" bIns="0" anchor="ctr">
-            <a:spAutoFit/>
+            <a:normAutofit/>
           </a:bodyPr>
           <a:lstStyle/>
           <a:p>
             <a:pPr algn="l"/>
             <a:r>
-              <a:rPr sz="835" b="0">
+              <a:rPr sz="1050" b="0">
                 <a:solidFill>
                   <a:srgbClr val="607084"/>
                 </a:solidFill>
                 <a:latin typeface="Aptos"/>
               </a:rPr>
-              <a:t>LED is on the 24 V CONTROL circuit, not the external heater: HL1/HL2 = RS 130-1086, yellow, 24 V DC, 20 mA max.</a:t>
+              <a:t>ACTIVE+ shares Crydom +3 / SB1 COM gated +24 V. ENABLE LED+ instead comes from Finder K1:14 (EN1).</a:t>
             </a:r>
           </a:p>
         </p:txBody>
@@ -23465,19 +23465,19 @@
         </p:spPr>
         <p:txBody>
           <a:bodyPr wrap="none" lIns="9144" tIns="0" rIns="9144" bIns="0" anchor="ctr">
-            <a:spAutoFit/>
+            <a:normAutofit/>
           </a:bodyPr>
           <a:lstStyle/>
           <a:p>
             <a:pPr algn="l"/>
             <a:r>
-              <a:rPr sz="950" b="0">
+              <a:rPr sz="1000" b="0">
                 <a:solidFill>
                   <a:srgbClr val="607084"/>
                 </a:solidFill>
                 <a:latin typeface="Aptos"/>
               </a:rPr>
-              <a:t>From selector</a:t>
+              <a:t>SB1 COM (reported)</a:t>
             </a:r>
           </a:p>
         </p:txBody>
@@ -25671,19 +25671,19 @@
         </p:spPr>
         <p:txBody>
           <a:bodyPr wrap="none" lIns="9144" tIns="0" rIns="9144" bIns="0" anchor="ctr">
-            <a:spAutoFit/>
+            <a:normAutofit/>
           </a:bodyPr>
           <a:lstStyle/>
           <a:p>
             <a:pPr algn="l"/>
             <a:r>
-              <a:rPr sz="865" b="1">
+              <a:rPr sz="1050" b="1">
                 <a:solidFill>
                   <a:srgbClr val="607084"/>
                 </a:solidFill>
                 <a:latin typeface="Aptos"/>
               </a:rPr>
-              <a:t>W13: switched returns  |  W14: 0 V</a:t>
+              <a:t>W1:13 = SSR -4 &amp; ACTIVE-  |  W1:14 = 0 V</a:t>
             </a:r>
           </a:p>
         </p:txBody>
@@ -25741,19 +25741,19 @@
         </p:spPr>
         <p:txBody>
           <a:bodyPr wrap="square" lIns="9144" tIns="0" rIns="9144" bIns="0" anchor="ctr">
-            <a:spAutoFit/>
+            <a:normAutofit/>
           </a:bodyPr>
           <a:lstStyle/>
           <a:p>
             <a:pPr algn="l"/>
             <a:r>
-              <a:rPr sz="900" b="0">
+              <a:rPr sz="1000" b="0">
                 <a:solidFill>
                   <a:srgbClr val="A35B1B"/>
                 </a:solidFill>
                 <a:latin typeface="Aptos"/>
               </a:rPr>
-              <a:t>Datasheet budget: SSR max 15 mA + HL yellow LED max 20 mA = 35 mA per channel; W1/W2 DC1 output max 100 mA. Verify live circuit.</a:t>
+              <a:t>REPORTED: Crydom +3 shares SB1 COM +24 V; ACTIVE+ also on gated +24. Crydom -4 and ACTIVE- join W1:13; W1:14 -&gt; 0 V. Inspect terminals and junctions; load budget max 35 mA.</a:t>
             </a:r>
           </a:p>
         </p:txBody>
@@ -26286,7 +26286,7 @@
         </p:spPr>
         <p:txBody>
           <a:bodyPr wrap="none" lIns="9144" tIns="0" rIns="9144" bIns="0" anchor="ctr">
-            <a:spAutoFit/>
+            <a:normAutofit/>
           </a:bodyPr>
           <a:lstStyle/>
           <a:p>
@@ -26298,7 +26298,7 @@
                 </a:solidFill>
                 <a:latin typeface="Aptos"/>
               </a:rPr>
-              <a:t>HEATING RATE CONTROLLER   /   D12 BLOCK + PORT SCHEMATICS   /   EDITABLE POWERPOINT</a:t>
+              <a:t>HEATING RATE CONTROLLER   /   D13 BLOCK + PORT SCHEMATICS   /   EDITABLE POWERPOINT</a:t>
             </a:r>
           </a:p>
         </p:txBody>
@@ -26356,19 +26356,19 @@
         </p:spPr>
         <p:txBody>
           <a:bodyPr wrap="none" lIns="9144" tIns="0" rIns="9144" bIns="0" anchor="ctr">
-            <a:spAutoFit/>
+            <a:normAutofit/>
           </a:bodyPr>
           <a:lstStyle/>
           <a:p>
             <a:pPr algn="l"/>
             <a:r>
-              <a:rPr sz="835" b="0">
+              <a:rPr sz="1050" b="0">
                 <a:solidFill>
                   <a:srgbClr val="607084"/>
                 </a:solidFill>
                 <a:latin typeface="Aptos"/>
               </a:rPr>
-              <a:t>LED is on the 24 V CONTROL circuit, not the external heater: HL1/HL2 = RS 130-1086, yellow, 24 V DC, 20 mA max.</a:t>
+              <a:t>ACTIVE+ shares Crydom +3 / SB2 COM gated +24 V. ENABLE LED+ instead comes from Finder K2:14 (EN2).</a:t>
             </a:r>
           </a:p>
         </p:txBody>
@@ -27348,19 +27348,19 @@
         </p:spPr>
         <p:txBody>
           <a:bodyPr wrap="none" lIns="9144" tIns="0" rIns="9144" bIns="0" anchor="ctr">
-            <a:spAutoFit/>
+            <a:normAutofit/>
           </a:bodyPr>
           <a:lstStyle/>
           <a:p>
             <a:pPr algn="l"/>
             <a:r>
-              <a:rPr sz="950" b="0">
+              <a:rPr sz="1000" b="0">
                 <a:solidFill>
                   <a:srgbClr val="607084"/>
                 </a:solidFill>
                 <a:latin typeface="Aptos"/>
               </a:rPr>
-              <a:t>From selector</a:t>
+              <a:t>SB2 COM (verify)</a:t>
             </a:r>
           </a:p>
         </p:txBody>
@@ -29554,19 +29554,19 @@
         </p:spPr>
         <p:txBody>
           <a:bodyPr wrap="none" lIns="9144" tIns="0" rIns="9144" bIns="0" anchor="ctr">
-            <a:spAutoFit/>
+            <a:normAutofit/>
           </a:bodyPr>
           <a:lstStyle/>
           <a:p>
             <a:pPr algn="l"/>
             <a:r>
-              <a:rPr sz="865" b="1">
+              <a:rPr sz="1050" b="1">
                 <a:solidFill>
                   <a:srgbClr val="607084"/>
                 </a:solidFill>
                 <a:latin typeface="Aptos"/>
               </a:rPr>
-              <a:t>W13: switched returns  |  W14: 0 V</a:t>
+              <a:t>W2:13 = SSR -4 &amp; ACTIVE-  |  W2:14 = 0 V</a:t>
             </a:r>
           </a:p>
         </p:txBody>
@@ -29624,19 +29624,19 @@
         </p:spPr>
         <p:txBody>
           <a:bodyPr wrap="square" lIns="9144" tIns="0" rIns="9144" bIns="0" anchor="ctr">
-            <a:spAutoFit/>
+            <a:normAutofit/>
           </a:bodyPr>
           <a:lstStyle/>
           <a:p>
             <a:pPr algn="l"/>
             <a:r>
-              <a:rPr sz="900" b="0">
+              <a:rPr sz="1000" b="0">
                 <a:solidFill>
                   <a:srgbClr val="A35B1B"/>
                 </a:solidFill>
                 <a:latin typeface="Aptos"/>
               </a:rPr>
-              <a:t>Datasheet budget: SSR max 15 mA + HL yellow LED max 20 mA = 35 mA per channel; W1/W2 DC1 output max 100 mA. Verify live circuit.</a:t>
+              <a:t>PROPOSED: Crydom +3 shares SB2 COM +24 V; ACTIVE+ also on gated +24. Crydom -4 and ACTIVE- join W2:13; W2:14 -&gt; 0 V. Independently verify CH2; max 35 mA budget.</a:t>
             </a:r>
           </a:p>
         </p:txBody>
@@ -30169,7 +30169,7 @@
         </p:spPr>
         <p:txBody>
           <a:bodyPr wrap="none" lIns="9144" tIns="0" rIns="9144" bIns="0" anchor="ctr">
-            <a:spAutoFit/>
+            <a:normAutofit/>
           </a:bodyPr>
           <a:lstStyle/>
           <a:p>
@@ -30181,7 +30181,7 @@
                 </a:solidFill>
                 <a:latin typeface="Aptos"/>
               </a:rPr>
-              <a:t>HEATING RATE CONTROLLER   /   D12 BLOCK + PORT SCHEMATICS   /   EDITABLE POWERPOINT</a:t>
+              <a:t>HEATING RATE CONTROLLER   /   D13 BLOCK + PORT SCHEMATICS   /   EDITABLE POWERPOINT</a:t>
             </a:r>
           </a:p>
         </p:txBody>
@@ -33110,20 +33110,19 @@
         </p:spPr>
         <p:txBody>
           <a:bodyPr wrap="square" lIns="9144" tIns="0" rIns="9144" bIns="0" anchor="ctr">
-            <a:spAutoFit/>
+            <a:normAutofit/>
           </a:bodyPr>
           <a:lstStyle/>
           <a:p>
             <a:pPr algn="l"/>
             <a:r>
-              <a:rPr sz="935" b="0">
+              <a:rPr sz="1050" b="0">
                 <a:solidFill>
                   <a:srgbClr val="1F344E"/>
                 </a:solidFill>
                 <a:latin typeface="Aptos"/>
               </a:rPr>
-              <a:t>Finder terminal 14 (−) and SSR load −2 remain in the POSITIVE conductor — neither is the supply 0 V.
-Breaker coordination, socket/contact derating and SSR heat dissipation require design approval.</a:t>
+              <a:t>Finder 62.31 contact 14(-) and Crydom load -2 BOTH remain on switched DC POSITIVE, not DC negative. Verify 15 A contact/socket, breaker and SSR thermal ratings.</a:t>
             </a:r>
           </a:p>
         </p:txBody>
@@ -33575,7 +33574,7 @@
         </p:spPr>
         <p:txBody>
           <a:bodyPr wrap="none" lIns="9144" tIns="0" rIns="9144" bIns="0" anchor="ctr">
-            <a:spAutoFit/>
+            <a:normAutofit/>
           </a:bodyPr>
           <a:lstStyle/>
           <a:p>
@@ -33587,7 +33586,7 @@
                 </a:solidFill>
                 <a:latin typeface="Aptos"/>
               </a:rPr>
-              <a:t>HEATING RATE CONTROLLER   /   D12 BLOCK + PORT SCHEMATICS   /   EDITABLE POWERPOINT</a:t>
+              <a:t>HEATING RATE CONTROLLER   /   D13 BLOCK + PORT SCHEMATICS   /   EDITABLE POWERPOINT</a:t>
             </a:r>
           </a:p>
         </p:txBody>
@@ -36516,20 +36515,19 @@
         </p:spPr>
         <p:txBody>
           <a:bodyPr wrap="square" lIns="9144" tIns="0" rIns="9144" bIns="0" anchor="ctr">
-            <a:spAutoFit/>
+            <a:normAutofit/>
           </a:bodyPr>
           <a:lstStyle/>
           <a:p>
             <a:pPr algn="l"/>
             <a:r>
-              <a:rPr sz="935" b="0">
+              <a:rPr sz="1050" b="0">
                 <a:solidFill>
                   <a:srgbClr val="1F344E"/>
                 </a:solidFill>
                 <a:latin typeface="Aptos"/>
               </a:rPr>
-              <a:t>Finder terminal 14 (−) and SSR load −2 remain in the POSITIVE conductor — neither is the supply 0 V.
-Breaker coordination, socket/contact derating and SSR heat dissipation require design approval.</a:t>
+              <a:t>Finder 62.31 contact 14(-) and Crydom load -2 BOTH remain on switched DC POSITIVE, not DC negative. Verify 15 A contact/socket, breaker and SSR thermal ratings.</a:t>
             </a:r>
           </a:p>
         </p:txBody>
@@ -36981,7 +36979,7 @@
         </p:spPr>
         <p:txBody>
           <a:bodyPr wrap="none" lIns="9144" tIns="0" rIns="9144" bIns="0" anchor="ctr">
-            <a:spAutoFit/>
+            <a:normAutofit/>
           </a:bodyPr>
           <a:lstStyle/>
           <a:p>
@@ -36993,7 +36991,7 @@
                 </a:solidFill>
                 <a:latin typeface="Aptos"/>
               </a:rPr>
-              <a:t>HEATING RATE CONTROLLER   /   D12 BLOCK + PORT SCHEMATICS   /   EDITABLE POWERPOINT</a:t>
+              <a:t>HEATING RATE CONTROLLER   /   D13 BLOCK + PORT SCHEMATICS   /   EDITABLE POWERPOINT</a:t>
             </a:r>
           </a:p>
         </p:txBody>
@@ -37051,19 +37049,19 @@
         </p:spPr>
         <p:txBody>
           <a:bodyPr wrap="none" lIns="9144" tIns="0" rIns="9144" bIns="0" anchor="ctr">
-            <a:spAutoFit/>
+            <a:normAutofit/>
           </a:bodyPr>
           <a:lstStyle/>
           <a:p>
             <a:pPr algn="l"/>
             <a:r>
-              <a:rPr sz="835" b="0">
+              <a:rPr sz="1070" b="0">
                 <a:solidFill>
                   <a:srgbClr val="607084"/>
                 </a:solidFill>
                 <a:latin typeface="Aptos"/>
               </a:rPr>
-              <a:t>Any X1–X4 numbers are logical net references until actual terminal blocks/jumpers are documented.</a:t>
+              <a:t>Cabinet TOTAL: X1 supplies 3 outgoing L and 3 outgoing N. Incoming L/N, selector-to-Omron Live wires and protective earth are ADDITIONAL.</a:t>
             </a:r>
           </a:p>
         </p:txBody>
@@ -37917,19 +37915,19 @@
         </p:spPr>
         <p:txBody>
           <a:bodyPr wrap="none" lIns="9144" tIns="0" rIns="9144" bIns="0" anchor="ctr">
-            <a:spAutoFit/>
+            <a:normAutofit/>
           </a:bodyPr>
           <a:lstStyle/>
           <a:p>
             <a:pPr algn="l"/>
             <a:r>
-              <a:rPr sz="969" b="0">
+              <a:rPr sz="1100" b="0">
                 <a:solidFill>
                   <a:srgbClr val="1F344E"/>
                 </a:solidFill>
                 <a:latin typeface="Aptos"/>
               </a:rPr>
-              <a:t>X1:L / N / PE</a:t>
+              <a:t>X1:L / X1:N / PE (3 paths)</a:t>
             </a:r>
           </a:p>
         </p:txBody>
@@ -37987,19 +37985,19 @@
         </p:spPr>
         <p:txBody>
           <a:bodyPr wrap="none" lIns="9144" tIns="0" rIns="9144" bIns="0" anchor="ctr">
-            <a:spAutoFit/>
+            <a:normAutofit/>
           </a:bodyPr>
           <a:lstStyle/>
           <a:p>
             <a:pPr algn="l"/>
             <a:r>
-              <a:rPr sz="969" b="0">
+              <a:rPr sz="1100" b="0">
                 <a:solidFill>
                   <a:srgbClr val="1F344E"/>
                 </a:solidFill>
                 <a:latin typeface="Aptos"/>
               </a:rPr>
-              <a:t>PS1:C1 / C2 / C3</a:t>
+              <a:t>PS1:C1 (L) / C2 (N) / C3 (FG)</a:t>
             </a:r>
           </a:p>
         </p:txBody>
@@ -38151,19 +38149,19 @@
         </p:spPr>
         <p:txBody>
           <a:bodyPr wrap="none" lIns="9144" tIns="0" rIns="9144" bIns="0" anchor="ctr">
-            <a:spAutoFit/>
+            <a:normAutofit/>
           </a:bodyPr>
           <a:lstStyle/>
           <a:p>
             <a:pPr algn="l"/>
             <a:r>
-              <a:rPr sz="969" b="0">
+              <a:rPr sz="1100" b="0">
                 <a:solidFill>
                   <a:srgbClr val="1F344E"/>
                 </a:solidFill>
                 <a:latin typeface="Aptos"/>
               </a:rPr>
-              <a:t>X1:L → S1-A:13/14</a:t>
+              <a:t>X1:L -&gt; S1-A 13 -&gt; S1-A 14</a:t>
             </a:r>
           </a:p>
         </p:txBody>
@@ -38221,19 +38219,19 @@
         </p:spPr>
         <p:txBody>
           <a:bodyPr wrap="none" lIns="9144" tIns="0" rIns="9144" bIns="0" anchor="ctr">
-            <a:spAutoFit/>
+            <a:normAutofit/>
           </a:bodyPr>
           <a:lstStyle/>
           <a:p>
             <a:pPr algn="l"/>
             <a:r>
-              <a:rPr sz="969" b="0">
+              <a:rPr sz="1100" b="0">
                 <a:solidFill>
                   <a:srgbClr val="1F344E"/>
                 </a:solidFill>
                 <a:latin typeface="Aptos"/>
               </a:rPr>
-              <a:t>E1:11 (L)</a:t>
+              <a:t>E1:11 (L); 2 physical wires</a:t>
             </a:r>
           </a:p>
         </p:txBody>
@@ -38619,19 +38617,19 @@
         </p:spPr>
         <p:txBody>
           <a:bodyPr wrap="none" lIns="9144" tIns="0" rIns="9144" bIns="0" anchor="ctr">
-            <a:spAutoFit/>
+            <a:normAutofit/>
           </a:bodyPr>
           <a:lstStyle/>
           <a:p>
             <a:pPr algn="l"/>
             <a:r>
-              <a:rPr sz="969" b="0">
+              <a:rPr sz="1100" b="0">
                 <a:solidFill>
                   <a:srgbClr val="1F344E"/>
                 </a:solidFill>
                 <a:latin typeface="Aptos"/>
               </a:rPr>
-              <a:t>X1:L → S2-A:13/14</a:t>
+              <a:t>X1:L -&gt; S2-A 13 -&gt; S2-A 14</a:t>
             </a:r>
           </a:p>
         </p:txBody>
@@ -38689,19 +38687,19 @@
         </p:spPr>
         <p:txBody>
           <a:bodyPr wrap="none" lIns="9144" tIns="0" rIns="9144" bIns="0" anchor="ctr">
-            <a:spAutoFit/>
+            <a:normAutofit/>
           </a:bodyPr>
           <a:lstStyle/>
           <a:p>
             <a:pPr algn="l"/>
             <a:r>
-              <a:rPr sz="969" b="0">
+              <a:rPr sz="1100" b="0">
                 <a:solidFill>
                   <a:srgbClr val="1F344E"/>
                 </a:solidFill>
                 <a:latin typeface="Aptos"/>
               </a:rPr>
-              <a:t>E2:11 (L)</a:t>
+              <a:t>E2:11 (L); 2 physical wires</a:t>
             </a:r>
           </a:p>
         </p:txBody>
@@ -40128,19 +40126,19 @@
         </p:spPr>
         <p:txBody>
           <a:bodyPr wrap="none" lIns="9144" tIns="0" rIns="9144" bIns="0" anchor="ctr">
-            <a:spAutoFit/>
+            <a:normAutofit/>
           </a:bodyPr>
           <a:lstStyle/>
           <a:p>
             <a:pPr algn="l"/>
             <a:r>
-              <a:rPr sz="900" b="0">
+              <a:rPr sz="1040" b="0">
                 <a:solidFill>
                   <a:srgbClr val="A35B1B"/>
                 </a:solidFill>
                 <a:latin typeface="Aptos"/>
               </a:rPr>
-              <a:t>Before wiring: confirm selector B contact-block stamps (*23/24 IEC proposed), J1 tabs, PE, X1–X4 blocks/jumpers and mains/24 V fuses.</a:t>
+              <a:t>Verify 3 L / 3 N X1 outgoing taps, all incoming conductors, selector NO markings, PE bonding, X1-X4 terminal blocks and approved ferrules.</a:t>
             </a:r>
           </a:p>
         </p:txBody>

</xml_diff>